<commit_message>
Add TTT Team 43 members and FinTech PS1 to pitch cover
</commit_message>
<xml_diff>
--- a/output/zev-submission-20261004/02_Upload/TTT Team_HacKU_Pitch.pptx
+++ b/output/zev-submission-20261004/02_Upload/TTT Team_HacKU_Pitch.pptx
@@ -7488,7 +7488,7 @@
 </file>
 
 <file path=ppt/slides/slide1.xml><?xml version="1.0" encoding="utf-8"?>
-<p:sld xmlns:p="http://schemas.openxmlformats.org/presentationml/2006/main" xmlns:a="http://schemas.openxmlformats.org/drawingml/2006/main" xmlns:r="http://schemas.openxmlformats.org/officeDocument/2006/relationships">
+<p:sld xmlns:a="http://schemas.openxmlformats.org/drawingml/2006/main" xmlns:ns3="http://schemas.microsoft.com/office/drawing/2014/main" xmlns:p="http://schemas.openxmlformats.org/presentationml/2006/main" xmlns:r="http://schemas.openxmlformats.org/officeDocument/2006/relationships">
   <p:cSld>
     <p:spTree>
       <p:nvGrpSpPr>
@@ -7946,6 +7946,405 @@
                 <a:sym typeface="Arial Bold"/>
               </a:rPr>
               <a:t>Trust   /   E-commerce   /   Agent   /   Payment</a:t>
+            </a:r>
+          </a:p>
+        </p:txBody>
+      </p:sp>
+      <p:sp>
+        <p:nvSpPr>
+          <p:cNvPr id="12" name="Team and problem statement 12">
+            <a:extLst>
+              <a:ext uri="{FF2B5EF4-FFF2-40B4-BE49-F238E27FC236}">
+                <ns3:creationId id="{9F49CAC8-EC9C-4463-97AE-FB96D28DABAC}"/>
+              </a:ext>
+            </a:extLst>
+          </p:cNvPr>
+          <p:cNvSpPr>
+            <a:spLocks noGrp="1"/>
+          </p:cNvSpPr>
+          <p:nvPr/>
+        </p:nvSpPr>
+        <p:spPr>
+          <a:xfrm>
+            <a:off x="11382375" y="685800"/>
+            <a:ext cx="6000750" cy="476250"/>
+          </a:xfrm>
+          <a:prstGeom prst="rect">
+            <a:avLst/>
+          </a:prstGeom>
+          <a:noFill/>
+          <a:ln w="0">
+            <a:noFill/>
+          </a:ln>
+        </p:spPr>
+        <p:txBody>
+          <a:bodyPr>
+            <a:noAutofit/>
+          </a:bodyPr>
+          <a:lstStyle/>
+          <a:p>
+            <a:pPr>
+              <a:defRPr sz="2850" b="1">
+                <a:solidFill>
+                  <a:srgbClr val="19171F"/>
+                </a:solidFill>
+                <a:latin typeface="Arial"/>
+                <a:ea typeface="Arial"/>
+                <a:cs typeface="Arial"/>
+              </a:defRPr>
+            </a:pPr>
+            <a:r>
+              <a:rPr sz="2850" b="1">
+                <a:solidFill>
+                  <a:srgbClr val="19171F"/>
+                </a:solidFill>
+                <a:latin typeface="Arial"/>
+                <a:ea typeface="Arial"/>
+                <a:cs typeface="Arial"/>
+              </a:rPr>
+              <a:t>No.43   TTT Team</a:t>
+            </a:r>
+          </a:p>
+        </p:txBody>
+      </p:sp>
+      <p:sp>
+        <p:nvSpPr>
+          <p:cNvPr id="13" name="Team and problem statement 13">
+            <a:extLst>
+              <a:ext uri="{FF2B5EF4-FFF2-40B4-BE49-F238E27FC236}">
+                <ns3:creationId id="{D087E82A-683A-4D93-BFFC-50CA43750042}"/>
+              </a:ext>
+            </a:extLst>
+          </p:cNvPr>
+          <p:cNvSpPr>
+            <a:spLocks noGrp="1"/>
+          </p:cNvSpPr>
+          <p:nvPr/>
+        </p:nvSpPr>
+        <p:spPr>
+          <a:xfrm>
+            <a:off x="11382375" y="1257300"/>
+            <a:ext cx="2857500" cy="400050"/>
+          </a:xfrm>
+          <a:prstGeom prst="rect">
+            <a:avLst/>
+          </a:prstGeom>
+          <a:noFill/>
+          <a:ln w="0">
+            <a:noFill/>
+          </a:ln>
+        </p:spPr>
+        <p:txBody>
+          <a:bodyPr>
+            <a:noAutofit/>
+          </a:bodyPr>
+          <a:lstStyle/>
+          <a:p>
+            <a:pPr>
+              <a:defRPr sz="2175" b="0">
+                <a:solidFill>
+                  <a:srgbClr val="6B6779"/>
+                </a:solidFill>
+                <a:latin typeface="Arial"/>
+                <a:ea typeface="Arial"/>
+                <a:cs typeface="Arial"/>
+              </a:defRPr>
+            </a:pPr>
+            <a:r>
+              <a:rPr sz="2175" b="0">
+                <a:solidFill>
+                  <a:srgbClr val="6B6779"/>
+                </a:solidFill>
+                <a:latin typeface="Arial"/>
+                <a:ea typeface="Arial"/>
+                <a:cs typeface="Arial"/>
+              </a:rPr>
+              <a:t>Jingxuan XIE</a:t>
+            </a:r>
+          </a:p>
+        </p:txBody>
+      </p:sp>
+      <p:sp>
+        <p:nvSpPr>
+          <p:cNvPr id="14" name="Team and problem statement 14">
+            <a:extLst>
+              <a:ext uri="{FF2B5EF4-FFF2-40B4-BE49-F238E27FC236}">
+                <ns3:creationId id="{4B7A23D5-9C30-4842-A946-EE4D2069BA35}"/>
+              </a:ext>
+            </a:extLst>
+          </p:cNvPr>
+          <p:cNvSpPr>
+            <a:spLocks noGrp="1"/>
+          </p:cNvSpPr>
+          <p:nvPr/>
+        </p:nvSpPr>
+        <p:spPr>
+          <a:xfrm>
+            <a:off x="14430375" y="1257300"/>
+            <a:ext cx="2952750" cy="400050"/>
+          </a:xfrm>
+          <a:prstGeom prst="rect">
+            <a:avLst/>
+          </a:prstGeom>
+          <a:noFill/>
+          <a:ln w="0">
+            <a:noFill/>
+          </a:ln>
+        </p:spPr>
+        <p:txBody>
+          <a:bodyPr>
+            <a:noAutofit/>
+          </a:bodyPr>
+          <a:lstStyle/>
+          <a:p>
+            <a:pPr>
+              <a:defRPr sz="2175" b="0">
+                <a:solidFill>
+                  <a:srgbClr val="6B6779"/>
+                </a:solidFill>
+                <a:latin typeface="Arial"/>
+                <a:ea typeface="Arial"/>
+                <a:cs typeface="Arial"/>
+              </a:defRPr>
+            </a:pPr>
+            <a:r>
+              <a:rPr sz="2175" b="0">
+                <a:solidFill>
+                  <a:srgbClr val="6B6779"/>
+                </a:solidFill>
+                <a:latin typeface="Arial"/>
+                <a:ea typeface="Arial"/>
+                <a:cs typeface="Arial"/>
+              </a:rPr>
+              <a:t>Siyuan ZOU</a:t>
+            </a:r>
+          </a:p>
+        </p:txBody>
+      </p:sp>
+      <p:sp>
+        <p:nvSpPr>
+          <p:cNvPr id="15" name="Team and problem statement 15">
+            <a:extLst>
+              <a:ext uri="{FF2B5EF4-FFF2-40B4-BE49-F238E27FC236}">
+                <ns3:creationId id="{FEBF6E7F-84CA-4605-813A-9C4EE1FD5600}"/>
+              </a:ext>
+            </a:extLst>
+          </p:cNvPr>
+          <p:cNvSpPr>
+            <a:spLocks noGrp="1"/>
+          </p:cNvSpPr>
+          <p:nvPr/>
+        </p:nvSpPr>
+        <p:spPr>
+          <a:xfrm>
+            <a:off x="11382375" y="1685925"/>
+            <a:ext cx="2857500" cy="400050"/>
+          </a:xfrm>
+          <a:prstGeom prst="rect">
+            <a:avLst/>
+          </a:prstGeom>
+          <a:noFill/>
+          <a:ln w="0">
+            <a:noFill/>
+          </a:ln>
+        </p:spPr>
+        <p:txBody>
+          <a:bodyPr>
+            <a:noAutofit/>
+          </a:bodyPr>
+          <a:lstStyle/>
+          <a:p>
+            <a:pPr>
+              <a:defRPr sz="2175" b="0">
+                <a:solidFill>
+                  <a:srgbClr val="6B6779"/>
+                </a:solidFill>
+                <a:latin typeface="Arial"/>
+                <a:ea typeface="Arial"/>
+                <a:cs typeface="Arial"/>
+              </a:defRPr>
+            </a:pPr>
+            <a:r>
+              <a:rPr sz="2175" b="0">
+                <a:solidFill>
+                  <a:srgbClr val="6B6779"/>
+                </a:solidFill>
+                <a:latin typeface="Arial"/>
+                <a:ea typeface="Arial"/>
+                <a:cs typeface="Arial"/>
+              </a:rPr>
+              <a:t>Qicheng LI</a:t>
+            </a:r>
+          </a:p>
+        </p:txBody>
+      </p:sp>
+      <p:sp>
+        <p:nvSpPr>
+          <p:cNvPr id="16" name="Team and problem statement 16">
+            <a:extLst>
+              <a:ext uri="{FF2B5EF4-FFF2-40B4-BE49-F238E27FC236}">
+                <ns3:creationId id="{265CBBF0-FFE0-443F-8BD4-B703E63B43DF}"/>
+              </a:ext>
+            </a:extLst>
+          </p:cNvPr>
+          <p:cNvSpPr>
+            <a:spLocks noGrp="1"/>
+          </p:cNvSpPr>
+          <p:nvPr/>
+        </p:nvSpPr>
+        <p:spPr>
+          <a:xfrm>
+            <a:off x="14430375" y="1685925"/>
+            <a:ext cx="2952750" cy="400050"/>
+          </a:xfrm>
+          <a:prstGeom prst="rect">
+            <a:avLst/>
+          </a:prstGeom>
+          <a:noFill/>
+          <a:ln w="0">
+            <a:noFill/>
+          </a:ln>
+        </p:spPr>
+        <p:txBody>
+          <a:bodyPr>
+            <a:noAutofit/>
+          </a:bodyPr>
+          <a:lstStyle/>
+          <a:p>
+            <a:pPr>
+              <a:defRPr sz="2175" b="0">
+                <a:solidFill>
+                  <a:srgbClr val="6B6779"/>
+                </a:solidFill>
+                <a:latin typeface="Arial"/>
+                <a:ea typeface="Arial"/>
+                <a:cs typeface="Arial"/>
+              </a:defRPr>
+            </a:pPr>
+            <a:r>
+              <a:rPr sz="2175" b="0">
+                <a:solidFill>
+                  <a:srgbClr val="6B6779"/>
+                </a:solidFill>
+                <a:latin typeface="Arial"/>
+                <a:ea typeface="Arial"/>
+                <a:cs typeface="Arial"/>
+              </a:rPr>
+              <a:t>Yiyun QI</a:t>
+            </a:r>
+          </a:p>
+        </p:txBody>
+      </p:sp>
+      <p:sp>
+        <p:nvSpPr>
+          <p:cNvPr id="17" name="Team and problem statement 17">
+            <a:extLst>
+              <a:ext uri="{FF2B5EF4-FFF2-40B4-BE49-F238E27FC236}">
+                <ns3:creationId id="{F4D78316-03FB-4CBA-9436-B7C12C9461AE}"/>
+              </a:ext>
+            </a:extLst>
+          </p:cNvPr>
+          <p:cNvSpPr>
+            <a:spLocks noGrp="1"/>
+          </p:cNvSpPr>
+          <p:nvPr/>
+        </p:nvSpPr>
+        <p:spPr>
+          <a:xfrm>
+            <a:off x="11382375" y="2238375"/>
+            <a:ext cx="6000750" cy="361950"/>
+          </a:xfrm>
+          <a:prstGeom prst="rect">
+            <a:avLst/>
+          </a:prstGeom>
+          <a:noFill/>
+          <a:ln w="0">
+            <a:noFill/>
+          </a:ln>
+        </p:spPr>
+        <p:txBody>
+          <a:bodyPr>
+            <a:noAutofit/>
+          </a:bodyPr>
+          <a:lstStyle/>
+          <a:p>
+            <a:pPr>
+              <a:defRPr sz="2100" b="1">
+                <a:solidFill>
+                  <a:srgbClr val="6650D7"/>
+                </a:solidFill>
+                <a:latin typeface="Arial"/>
+                <a:ea typeface="Arial"/>
+                <a:cs typeface="Arial"/>
+              </a:defRPr>
+            </a:pPr>
+            <a:r>
+              <a:rPr sz="2100" b="1">
+                <a:solidFill>
+                  <a:srgbClr val="6650D7"/>
+                </a:solidFill>
+                <a:latin typeface="Arial"/>
+                <a:ea typeface="Arial"/>
+                <a:cs typeface="Arial"/>
+              </a:rPr>
+              <a:t>FinTech - Problem Statement 1</a:t>
+            </a:r>
+          </a:p>
+        </p:txBody>
+      </p:sp>
+      <p:sp>
+        <p:nvSpPr>
+          <p:cNvPr id="18" name="Team and problem statement 18">
+            <a:extLst>
+              <a:ext uri="{FF2B5EF4-FFF2-40B4-BE49-F238E27FC236}">
+                <ns3:creationId id="{FABF3D0F-5930-491E-879B-9525F22EEA0A}"/>
+              </a:ext>
+            </a:extLst>
+          </p:cNvPr>
+          <p:cNvSpPr>
+            <a:spLocks noGrp="1"/>
+          </p:cNvSpPr>
+          <p:nvPr/>
+        </p:nvSpPr>
+        <p:spPr>
+          <a:xfrm>
+            <a:off x="11382375" y="2647950"/>
+            <a:ext cx="6000750" cy="361950"/>
+          </a:xfrm>
+          <a:prstGeom prst="rect">
+            <a:avLst/>
+          </a:prstGeom>
+          <a:noFill/>
+          <a:ln w="0">
+            <a:noFill/>
+          </a:ln>
+        </p:spPr>
+        <p:txBody>
+          <a:bodyPr>
+            <a:noAutofit/>
+          </a:bodyPr>
+          <a:lstStyle/>
+          <a:p>
+            <a:pPr>
+              <a:defRPr sz="2100" b="0">
+                <a:solidFill>
+                  <a:srgbClr val="6650D7"/>
+                </a:solidFill>
+                <a:latin typeface="Arial"/>
+                <a:ea typeface="Arial"/>
+                <a:cs typeface="Arial"/>
+              </a:defRPr>
+            </a:pPr>
+            <a:r>
+              <a:rPr sz="2100" b="0">
+                <a:solidFill>
+                  <a:srgbClr val="6650D7"/>
+                </a:solidFill>
+                <a:latin typeface="Arial"/>
+                <a:ea typeface="Arial"/>
+                <a:cs typeface="Arial"/>
+              </a:rPr>
+              <a:t>Agentic Commerce</a:t>
             </a:r>
           </a:p>
         </p:txBody>

</xml_diff>